<commit_message>
feat: add match predictor model and update project presentation slides
</commit_message>
<xml_diff>
--- a/arenapulse.pptx
+++ b/arenapulse.pptx
@@ -289,7 +289,7 @@
           <a:p>
             <a:fld id="{97A9EA6D-B83E-4AB5-8B69-346DCA8967D7}" type="datetimeFigureOut">
               <a:rPr lang="en-IN" smtClean="0"/>
-              <a:t>02-08-2026</a:t>
+              <a:t>06-08-2026</a:t>
             </a:fld>
             <a:endParaRPr lang="en-IN"/>
           </a:p>
@@ -489,7 +489,7 @@
           <a:p>
             <a:fld id="{97A9EA6D-B83E-4AB5-8B69-346DCA8967D7}" type="datetimeFigureOut">
               <a:rPr lang="en-IN" smtClean="0"/>
-              <a:t>02-08-2026</a:t>
+              <a:t>06-08-2026</a:t>
             </a:fld>
             <a:endParaRPr lang="en-IN"/>
           </a:p>
@@ -699,7 +699,7 @@
           <a:p>
             <a:fld id="{97A9EA6D-B83E-4AB5-8B69-346DCA8967D7}" type="datetimeFigureOut">
               <a:rPr lang="en-IN" smtClean="0"/>
-              <a:t>02-08-2026</a:t>
+              <a:t>06-08-2026</a:t>
             </a:fld>
             <a:endParaRPr lang="en-IN"/>
           </a:p>
@@ -899,7 +899,7 @@
           <a:p>
             <a:fld id="{97A9EA6D-B83E-4AB5-8B69-346DCA8967D7}" type="datetimeFigureOut">
               <a:rPr lang="en-IN" smtClean="0"/>
-              <a:t>02-08-2026</a:t>
+              <a:t>06-08-2026</a:t>
             </a:fld>
             <a:endParaRPr lang="en-IN"/>
           </a:p>
@@ -1175,7 +1175,7 @@
           <a:p>
             <a:fld id="{97A9EA6D-B83E-4AB5-8B69-346DCA8967D7}" type="datetimeFigureOut">
               <a:rPr lang="en-IN" smtClean="0"/>
-              <a:t>02-08-2026</a:t>
+              <a:t>06-08-2026</a:t>
             </a:fld>
             <a:endParaRPr lang="en-IN"/>
           </a:p>
@@ -1443,7 +1443,7 @@
           <a:p>
             <a:fld id="{97A9EA6D-B83E-4AB5-8B69-346DCA8967D7}" type="datetimeFigureOut">
               <a:rPr lang="en-IN" smtClean="0"/>
-              <a:t>02-08-2026</a:t>
+              <a:t>06-08-2026</a:t>
             </a:fld>
             <a:endParaRPr lang="en-IN"/>
           </a:p>
@@ -1858,7 +1858,7 @@
           <a:p>
             <a:fld id="{97A9EA6D-B83E-4AB5-8B69-346DCA8967D7}" type="datetimeFigureOut">
               <a:rPr lang="en-IN" smtClean="0"/>
-              <a:t>02-08-2026</a:t>
+              <a:t>06-08-2026</a:t>
             </a:fld>
             <a:endParaRPr lang="en-IN"/>
           </a:p>
@@ -2000,7 +2000,7 @@
           <a:p>
             <a:fld id="{97A9EA6D-B83E-4AB5-8B69-346DCA8967D7}" type="datetimeFigureOut">
               <a:rPr lang="en-IN" smtClean="0"/>
-              <a:t>02-08-2026</a:t>
+              <a:t>06-08-2026</a:t>
             </a:fld>
             <a:endParaRPr lang="en-IN"/>
           </a:p>
@@ -2113,7 +2113,7 @@
           <a:p>
             <a:fld id="{97A9EA6D-B83E-4AB5-8B69-346DCA8967D7}" type="datetimeFigureOut">
               <a:rPr lang="en-IN" smtClean="0"/>
-              <a:t>02-08-2026</a:t>
+              <a:t>06-08-2026</a:t>
             </a:fld>
             <a:endParaRPr lang="en-IN"/>
           </a:p>
@@ -2426,7 +2426,7 @@
           <a:p>
             <a:fld id="{97A9EA6D-B83E-4AB5-8B69-346DCA8967D7}" type="datetimeFigureOut">
               <a:rPr lang="en-IN" smtClean="0"/>
-              <a:t>02-08-2026</a:t>
+              <a:t>06-08-2026</a:t>
             </a:fld>
             <a:endParaRPr lang="en-IN"/>
           </a:p>
@@ -2715,7 +2715,7 @@
           <a:p>
             <a:fld id="{97A9EA6D-B83E-4AB5-8B69-346DCA8967D7}" type="datetimeFigureOut">
               <a:rPr lang="en-IN" smtClean="0"/>
-              <a:t>02-08-2026</a:t>
+              <a:t>06-08-2026</a:t>
             </a:fld>
             <a:endParaRPr lang="en-IN"/>
           </a:p>
@@ -2958,7 +2958,7 @@
           <a:p>
             <a:fld id="{97A9EA6D-B83E-4AB5-8B69-346DCA8967D7}" type="datetimeFigureOut">
               <a:rPr lang="en-IN" smtClean="0"/>
-              <a:t>02-08-2026</a:t>
+              <a:t>06-08-2026</a:t>
             </a:fld>
             <a:endParaRPr lang="en-IN"/>
           </a:p>
@@ -3399,7 +3399,7 @@
         </p:nvGrpSpPr>
         <p:grpSpPr>
           <a:xfrm>
-            <a:off x="2738757" y="665614"/>
+            <a:off x="2738757" y="1127528"/>
             <a:ext cx="6714486" cy="1494627"/>
             <a:chOff x="2408437" y="665614"/>
             <a:chExt cx="6714486" cy="1494627"/>
@@ -3540,162 +3540,6 @@
           </p:spPr>
         </p:pic>
       </p:grpSp>
-      <p:grpSp>
-        <p:nvGrpSpPr>
-          <p:cNvPr id="21" name="Group 20">
-            <a:extLst>
-              <a:ext uri="{FF2B5EF4-FFF2-40B4-BE49-F238E27FC236}">
-                <a16:creationId xmlns:a16="http://schemas.microsoft.com/office/drawing/2014/main" id="{A096A6BD-C791-843A-FA38-74E0B4499974}"/>
-              </a:ext>
-            </a:extLst>
-          </p:cNvPr>
-          <p:cNvGrpSpPr/>
-          <p:nvPr/>
-        </p:nvGrpSpPr>
-        <p:grpSpPr>
-          <a:xfrm>
-            <a:off x="2738757" y="2841783"/>
-            <a:ext cx="6714486" cy="923330"/>
-            <a:chOff x="2738757" y="2685500"/>
-            <a:chExt cx="6714486" cy="923330"/>
-          </a:xfrm>
-        </p:grpSpPr>
-        <p:sp>
-          <p:nvSpPr>
-            <p:cNvPr id="10" name="TextBox 9">
-              <a:extLst>
-                <a:ext uri="{FF2B5EF4-FFF2-40B4-BE49-F238E27FC236}">
-                  <a16:creationId xmlns:a16="http://schemas.microsoft.com/office/drawing/2014/main" id="{82220EDB-07F2-7FA3-7D94-93E8D62EA180}"/>
-                </a:ext>
-              </a:extLst>
-            </p:cNvPr>
-            <p:cNvSpPr txBox="1"/>
-            <p:nvPr/>
-          </p:nvSpPr>
-          <p:spPr>
-            <a:xfrm>
-              <a:off x="2901166" y="3147165"/>
-              <a:ext cx="1394934" cy="461665"/>
-            </a:xfrm>
-            <a:prstGeom prst="rect">
-              <a:avLst/>
-            </a:prstGeom>
-            <a:noFill/>
-          </p:spPr>
-          <p:txBody>
-            <a:bodyPr wrap="none" rtlCol="0">
-              <a:spAutoFit/>
-            </a:bodyPr>
-            <a:lstStyle/>
-            <a:p>
-              <a:r>
-                <a:rPr lang="en-IN" sz="2400" dirty="0">
-                  <a:latin typeface="Poppins SemiBold" panose="00000700000000000000" pitchFamily="2" charset="0"/>
-                  <a:cs typeface="Poppins SemiBold" panose="00000700000000000000" pitchFamily="2" charset="0"/>
-                </a:rPr>
-                <a:t>Sem : </a:t>
-              </a:r>
-              <a:r>
-                <a:rPr lang="en-IN" sz="2400" dirty="0">
-                  <a:latin typeface="Poppins" panose="00000500000000000000" pitchFamily="2" charset="0"/>
-                  <a:cs typeface="Poppins" panose="00000500000000000000" pitchFamily="2" charset="0"/>
-                </a:rPr>
-                <a:t>IV</a:t>
-              </a:r>
-            </a:p>
-          </p:txBody>
-        </p:sp>
-        <p:sp>
-          <p:nvSpPr>
-            <p:cNvPr id="11" name="TextBox 10">
-              <a:extLst>
-                <a:ext uri="{FF2B5EF4-FFF2-40B4-BE49-F238E27FC236}">
-                  <a16:creationId xmlns:a16="http://schemas.microsoft.com/office/drawing/2014/main" id="{1F873399-3574-E6E0-47E7-18A521D82356}"/>
-                </a:ext>
-              </a:extLst>
-            </p:cNvPr>
-            <p:cNvSpPr txBox="1"/>
-            <p:nvPr/>
-          </p:nvSpPr>
-          <p:spPr>
-            <a:xfrm>
-              <a:off x="5336410" y="2685500"/>
-              <a:ext cx="4116833" cy="461665"/>
-            </a:xfrm>
-            <a:prstGeom prst="rect">
-              <a:avLst/>
-            </a:prstGeom>
-            <a:noFill/>
-          </p:spPr>
-          <p:txBody>
-            <a:bodyPr wrap="none" rtlCol="0">
-              <a:spAutoFit/>
-            </a:bodyPr>
-            <a:lstStyle/>
-            <a:p>
-              <a:r>
-                <a:rPr lang="en-IN" sz="2400" dirty="0">
-                  <a:latin typeface="Poppins SemiBold" panose="00000700000000000000" pitchFamily="2" charset="0"/>
-                  <a:cs typeface="Poppins SemiBold" panose="00000700000000000000" pitchFamily="2" charset="0"/>
-                </a:rPr>
-                <a:t>Subject : </a:t>
-              </a:r>
-              <a:r>
-                <a:rPr lang="en-IN" sz="2400" dirty="0">
-                  <a:latin typeface="Poppins" panose="00000500000000000000" pitchFamily="2" charset="0"/>
-                  <a:cs typeface="Poppins" panose="00000500000000000000" pitchFamily="2" charset="0"/>
-                </a:rPr>
-                <a:t>Python-2 , FSD-2</a:t>
-              </a:r>
-            </a:p>
-          </p:txBody>
-        </p:sp>
-        <p:sp>
-          <p:nvSpPr>
-            <p:cNvPr id="12" name="TextBox 11">
-              <a:extLst>
-                <a:ext uri="{FF2B5EF4-FFF2-40B4-BE49-F238E27FC236}">
-                  <a16:creationId xmlns:a16="http://schemas.microsoft.com/office/drawing/2014/main" id="{66F87374-45F5-F3DB-7306-1847ABC51B31}"/>
-                </a:ext>
-              </a:extLst>
-            </p:cNvPr>
-            <p:cNvSpPr txBox="1"/>
-            <p:nvPr/>
-          </p:nvSpPr>
-          <p:spPr>
-            <a:xfrm>
-              <a:off x="2738757" y="2685500"/>
-              <a:ext cx="1660761" cy="461665"/>
-            </a:xfrm>
-            <a:prstGeom prst="rect">
-              <a:avLst/>
-            </a:prstGeom>
-            <a:noFill/>
-          </p:spPr>
-          <p:txBody>
-            <a:bodyPr wrap="square" lIns="91440" tIns="45720" rIns="91440" bIns="45720" rtlCol="0" anchor="t">
-              <a:spAutoFit/>
-            </a:bodyPr>
-            <a:lstStyle/>
-            <a:p>
-              <a:r>
-                <a:rPr lang="en-IN" sz="2400" dirty="0">
-                  <a:latin typeface="Poppins SemiBold"/>
-                  <a:cs typeface="Poppins SemiBold"/>
-                </a:rPr>
-                <a:t>Class : </a:t>
-              </a:r>
-              <a:r>
-                <a:rPr lang="en-IN" sz="2400" dirty="0">
-                  <a:latin typeface="Poppins"/>
-                  <a:cs typeface="Poppins"/>
-                </a:rPr>
-                <a:t>D2</a:t>
-              </a:r>
-            </a:p>
-          </p:txBody>
-        </p:sp>
-      </p:grpSp>
       <p:pic>
         <p:nvPicPr>
           <p:cNvPr id="6" name="Picture 5">
@@ -3776,7 +3620,7 @@
         </p:nvGrpSpPr>
         <p:grpSpPr>
           <a:xfrm>
-            <a:off x="1473003" y="4519225"/>
+            <a:off x="1473003" y="4085563"/>
             <a:ext cx="4622997" cy="1478204"/>
             <a:chOff x="1551560" y="4522513"/>
             <a:chExt cx="4622997" cy="1478204"/>
@@ -4049,7 +3893,7 @@
         </p:nvGrpSpPr>
         <p:grpSpPr>
           <a:xfrm>
-            <a:off x="6096000" y="4519225"/>
+            <a:off x="6096000" y="4085563"/>
             <a:ext cx="4622997" cy="1478204"/>
             <a:chOff x="1551560" y="4522513"/>
             <a:chExt cx="4622997" cy="1478204"/>
@@ -7901,10 +7745,10 @@
         </p:nvGrpSpPr>
         <p:grpSpPr>
           <a:xfrm>
-            <a:off x="571500" y="2274364"/>
-            <a:ext cx="7181850" cy="2730861"/>
+            <a:off x="571500" y="2583484"/>
+            <a:ext cx="7181850" cy="1691033"/>
             <a:chOff x="2278831" y="2637704"/>
-            <a:chExt cx="7181850" cy="2730861"/>
+            <a:chExt cx="7181850" cy="1691033"/>
           </a:xfrm>
         </p:grpSpPr>
         <p:grpSp>
@@ -8135,120 +7979,6 @@
             </p:spPr>
           </p:pic>
         </p:grpSp>
-        <p:grpSp>
-          <p:nvGrpSpPr>
-            <p:cNvPr id="14" name="Group 13">
-              <a:extLst>
-                <a:ext uri="{FF2B5EF4-FFF2-40B4-BE49-F238E27FC236}">
-                  <a16:creationId xmlns:a16="http://schemas.microsoft.com/office/drawing/2014/main" id="{02C90C37-2286-7342-1A02-7BC1289DC342}"/>
-                </a:ext>
-              </a:extLst>
-            </p:cNvPr>
-            <p:cNvGrpSpPr/>
-            <p:nvPr/>
-          </p:nvGrpSpPr>
-          <p:grpSpPr>
-            <a:xfrm>
-              <a:off x="2278832" y="4717361"/>
-              <a:ext cx="7181848" cy="651204"/>
-              <a:chOff x="571500" y="4364053"/>
-              <a:chExt cx="7181848" cy="651204"/>
-            </a:xfrm>
-          </p:grpSpPr>
-          <p:sp>
-            <p:nvSpPr>
-              <p:cNvPr id="15" name="TextBox 14">
-                <a:extLst>
-                  <a:ext uri="{FF2B5EF4-FFF2-40B4-BE49-F238E27FC236}">
-                    <a16:creationId xmlns:a16="http://schemas.microsoft.com/office/drawing/2014/main" id="{834438C6-58E9-2DFB-3BE6-040D1BDFD826}"/>
-                  </a:ext>
-                </a:extLst>
-              </p:cNvPr>
-              <p:cNvSpPr txBox="1"/>
-              <p:nvPr/>
-            </p:nvSpPr>
-            <p:spPr>
-              <a:xfrm>
-                <a:off x="1095373" y="4364053"/>
-                <a:ext cx="6657975" cy="651204"/>
-              </a:xfrm>
-              <a:prstGeom prst="rect">
-                <a:avLst/>
-              </a:prstGeom>
-              <a:noFill/>
-            </p:spPr>
-            <p:txBody>
-              <a:bodyPr wrap="square" lIns="0" tIns="0" rIns="0" bIns="0" anchor="t">
-                <a:spAutoFit/>
-              </a:bodyPr>
-              <a:lstStyle/>
-              <a:p>
-                <a:pPr algn="l">
-                  <a:lnSpc>
-                    <a:spcPts val="2640"/>
-                  </a:lnSpc>
-                </a:pPr>
-                <a:r>
-                  <a:rPr sz="2400" b="1" i="0" u="none" dirty="0">
-                    <a:solidFill>
-                      <a:srgbClr val="2563EB"/>
-                    </a:solidFill>
-                    <a:latin typeface="Inter"/>
-                  </a:rPr>
-                  <a:t>Skill-Based Clustering</a:t>
-                </a:r>
-                <a:r>
-                  <a:rPr lang="en-IN" sz="2000" b="1" i="0" u="none" dirty="0">
-                    <a:solidFill>
-                      <a:srgbClr val="2563EB"/>
-                    </a:solidFill>
-                    <a:latin typeface="Inter"/>
-                  </a:rPr>
-                  <a:t>:</a:t>
-                </a:r>
-                <a:r>
-                  <a:rPr sz="2000" b="0" i="0" u="none" dirty="0">
-                    <a:solidFill>
-                      <a:srgbClr val="475569"/>
-                    </a:solidFill>
-                    <a:latin typeface="Inter"/>
-                  </a:rPr>
-                  <a:t> AI-driven matchmaking to group players by skill tiers automatically.</a:t>
-                </a:r>
-              </a:p>
-            </p:txBody>
-          </p:sp>
-          <p:pic>
-            <p:nvPicPr>
-              <p:cNvPr id="21" name="Picture 20" descr="image.png">
-                <a:extLst>
-                  <a:ext uri="{FF2B5EF4-FFF2-40B4-BE49-F238E27FC236}">
-                    <a16:creationId xmlns:a16="http://schemas.microsoft.com/office/drawing/2014/main" id="{18575075-0AE9-F30D-50FD-75EBAFA89423}"/>
-                  </a:ext>
-                </a:extLst>
-              </p:cNvPr>
-              <p:cNvPicPr>
-                <a:picLocks noChangeAspect="1"/>
-              </p:cNvPicPr>
-              <p:nvPr/>
-            </p:nvPicPr>
-            <p:blipFill>
-              <a:blip r:embed="rId6"/>
-              <a:stretch>
-                <a:fillRect/>
-              </a:stretch>
-            </p:blipFill>
-            <p:spPr>
-              <a:xfrm>
-                <a:off x="571500" y="4450853"/>
-                <a:ext cx="333375" cy="276225"/>
-              </a:xfrm>
-              <a:prstGeom prst="rect">
-                <a:avLst/>
-              </a:prstGeom>
-            </p:spPr>
-          </p:pic>
-        </p:grpSp>
       </p:grpSp>
       <p:pic>
         <p:nvPicPr>
@@ -8265,7 +7995,7 @@
           <p:nvPr/>
         </p:nvPicPr>
         <p:blipFill>
-          <a:blip r:embed="rId7">
+          <a:blip r:embed="rId6">
             <a:extLst>
               <a:ext uri="{28A0092B-C50C-407E-A947-70E740481C1C}">
                 <a14:useLocalDpi xmlns:a14="http://schemas.microsoft.com/office/drawing/2010/main" val="0"/>

</xml_diff>